<commit_message>
Typeset the deck's equations with LaTeX
Unicode approximations of mathematics look like what they are. render_eq()
now compiles each equation block with tectonic, converts it to a transparent
PNG with pdftocairo, and caches the result in deck/eq/ under a hash of its
source. The PNGs are committed, so a rebuild needs LaTeX only when the
mathematics changes; stale entries are pruned automatically.

Per-line glosses are set in the same run, which keeps them aligned as a
column, and the surrounding prose no longer carries ASCII subscripts now
that the real thing sits beside it.

Co-Authored-By: Claude Opus 5 (1M context) <noreply@anthropic.com>
</commit_message>
<xml_diff>
--- a/deck/two-tier-scheduler.pptx
+++ b/deck/two-tier-scheduler.pptx
@@ -6207,7 +6207,7 @@
         <p:spPr>
           <a:xfrm>
             <a:off x="822960" y="1664208"/>
-            <a:ext cx="5760720" cy="352424"/>
+            <a:ext cx="5760720" cy="628650"/>
           </a:xfrm>
           <a:prstGeom prst="rect">
             <a:avLst/>
@@ -6235,186 +6235,35 @@
                 </a:solidFill>
                 <a:latin typeface="Calibri"/>
               </a:rPr>
-              <a:t>Rates r_i ≥ 0, slacks s ≥ 0, one feasible set F(floor):</a:t>
-            </a:r>
-          </a:p>
-        </p:txBody>
-      </p:sp>
-      <p:sp>
-        <p:nvSpPr>
-          <p:cNvPr id="6" name="TextBox 5"/>
-          <p:cNvSpPr txBox="1"/>
+              <a:t>Decision variables are a target rate per flow and the shortfall slacks. All solves share one feasible set:</a:t>
+            </a:r>
+          </a:p>
+        </p:txBody>
+      </p:sp>
+      <p:pic>
+        <p:nvPicPr>
+          <p:cNvPr id="6" name="Picture 5" descr="eq-f50d6a4aa5749e1a.png"/>
+          <p:cNvPicPr>
+            <a:picLocks noChangeAspect="1"/>
+          </p:cNvPicPr>
           <p:nvPr/>
-        </p:nvSpPr>
-        <p:spPr>
-          <a:xfrm>
-            <a:off x="822960" y="2144649"/>
-            <a:ext cx="5760720" cy="2141118"/>
+        </p:nvPicPr>
+        <p:blipFill>
+          <a:blip r:embed="rId2"/>
+          <a:stretch>
+            <a:fillRect/>
+          </a:stretch>
+        </p:blipFill>
+        <p:spPr>
+          <a:xfrm>
+            <a:off x="822960" y="2439162"/>
+            <a:ext cx="5760720" cy="1826866"/>
           </a:xfrm>
           <a:prstGeom prst="rect">
             <a:avLst/>
           </a:prstGeom>
-          <a:noFill/>
-        </p:spPr>
-        <p:txBody>
-          <a:bodyPr wrap="square">
-            <a:spAutoFit/>
-          </a:bodyPr>
-          <a:lstStyle/>
-          <a:p>
-            <a:pPr algn="l">
-              <a:lnSpc>
-                <a:spcPct val="130000"/>
-              </a:lnSpc>
-              <a:spcAft>
-                <a:spcPts val="0"/>
-              </a:spcAft>
-            </a:pPr>
-            <a:r>
-              <a:rPr sz="1400" b="0">
-                <a:solidFill>
-                  <a:srgbClr val="1A1A19"/>
-                </a:solidFill>
-                <a:latin typeface="Consolas"/>
-              </a:rPr>
-              <a:t>Σ_{i∈d} r_i / SE_i  ≤  C_d</a:t>
-            </a:r>
-          </a:p>
-          <a:p>
-            <a:pPr algn="l">
-              <a:lnSpc>
-                <a:spcPct val="110000"/>
-              </a:lnSpc>
-              <a:spcAft>
-                <a:spcPts val="700"/>
-              </a:spcAft>
-            </a:pPr>
-            <a:r>
-              <a:rPr sz="1100" b="0">
-                <a:solidFill>
-                  <a:srgbClr val="8A8980"/>
-                </a:solidFill>
-                <a:latin typeface="Calibri"/>
-              </a:rPr>
-              <a:t>capacity in PRB-symbols, special slot included</a:t>
-            </a:r>
-          </a:p>
-          <a:p>
-            <a:pPr algn="l">
-              <a:lnSpc>
-                <a:spcPct val="130000"/>
-              </a:lnSpc>
-              <a:spcAft>
-                <a:spcPts val="0"/>
-              </a:spcAft>
-            </a:pPr>
-            <a:r>
-              <a:rPr sz="1400" b="0">
-                <a:solidFill>
-                  <a:srgbClr val="1A1A19"/>
-                </a:solidFill>
-                <a:latin typeface="Consolas"/>
-              </a:rPr>
-              <a:t>r_i + s_i  ≥  G_i</a:t>
-            </a:r>
-          </a:p>
-          <a:p>
-            <a:pPr algn="l">
-              <a:lnSpc>
-                <a:spcPct val="110000"/>
-              </a:lnSpc>
-              <a:spcAft>
-                <a:spcPts val="700"/>
-              </a:spcAft>
-            </a:pPr>
-            <a:r>
-              <a:rPr sz="1100" b="0">
-                <a:solidFill>
-                  <a:srgbClr val="8A8980"/>
-                </a:solidFill>
-                <a:latin typeface="Calibri"/>
-              </a:rPr>
-              <a:t>GBR contract — soft, so overload stays feasible</a:t>
-            </a:r>
-          </a:p>
-          <a:p>
-            <a:pPr algn="l">
-              <a:lnSpc>
-                <a:spcPct val="130000"/>
-              </a:lnSpc>
-              <a:spcAft>
-                <a:spcPts val="0"/>
-              </a:spcAft>
-            </a:pPr>
-            <a:r>
-              <a:rPr sz="1400" b="0">
-                <a:solidFill>
-                  <a:srgbClr val="1A1A19"/>
-                </a:solidFill>
-                <a:latin typeface="Consolas"/>
-              </a:rPr>
-              <a:t>r_i  ≥  floor_i</a:t>
-            </a:r>
-          </a:p>
-          <a:p>
-            <a:pPr algn="l">
-              <a:lnSpc>
-                <a:spcPct val="110000"/>
-              </a:lnSpc>
-              <a:spcAft>
-                <a:spcPts val="700"/>
-              </a:spcAft>
-            </a:pPr>
-            <a:r>
-              <a:rPr sz="1100" b="0">
-                <a:solidFill>
-                  <a:srgbClr val="8A8980"/>
-                </a:solidFill>
-                <a:latin typeface="Calibri"/>
-              </a:rPr>
-              <a:t>max-min floor — hard</a:t>
-            </a:r>
-          </a:p>
-          <a:p>
-            <a:pPr algn="l">
-              <a:lnSpc>
-                <a:spcPct val="130000"/>
-              </a:lnSpc>
-              <a:spcAft>
-                <a:spcPts val="0"/>
-              </a:spcAft>
-            </a:pPr>
-            <a:r>
-              <a:rPr sz="1400" b="0">
-                <a:solidFill>
-                  <a:srgbClr val="1A1A19"/>
-                </a:solidFill>
-                <a:latin typeface="Consolas"/>
-              </a:rPr>
-              <a:t>Σ_{i∈σ} r_i/SE_i + s_σ  ≥  φ_σ·C_d</a:t>
-            </a:r>
-          </a:p>
-          <a:p>
-            <a:pPr algn="l">
-              <a:lnSpc>
-                <a:spcPct val="110000"/>
-              </a:lnSpc>
-              <a:spcAft>
-                <a:spcPts val="700"/>
-              </a:spcAft>
-            </a:pPr>
-            <a:r>
-              <a:rPr sz="1100" b="0">
-                <a:solidFill>
-                  <a:srgbClr val="8A8980"/>
-                </a:solidFill>
-                <a:latin typeface="Calibri"/>
-              </a:rPr>
-              <a:t>slice share — soft, demand-capped, work-conserving</a:t>
-            </a:r>
-          </a:p>
-        </p:txBody>
-      </p:sp>
+        </p:spPr>
+      </p:pic>
       <p:sp>
         <p:nvSpPr>
           <p:cNvPr id="7" name="TextBox 6"/>
@@ -6423,7 +6272,7 @@
         </p:nvSpPr>
         <p:spPr>
           <a:xfrm>
-            <a:off x="822960" y="4432071"/>
+            <a:off x="822960" y="4412332"/>
             <a:ext cx="5760720" cy="352424"/>
           </a:xfrm>
           <a:prstGeom prst="rect">
@@ -6457,105 +6306,30 @@
           </a:p>
         </p:txBody>
       </p:sp>
-      <p:sp>
-        <p:nvSpPr>
-          <p:cNvPr id="8" name="TextBox 7"/>
-          <p:cNvSpPr txBox="1"/>
+      <p:pic>
+        <p:nvPicPr>
+          <p:cNvPr id="8" name="Picture 7" descr="eq-50143fa3ad7f07fc.png"/>
+          <p:cNvPicPr>
+            <a:picLocks noChangeAspect="1"/>
+          </p:cNvPicPr>
           <p:nvPr/>
-        </p:nvSpPr>
-        <p:spPr>
-          <a:xfrm>
-            <a:off x="822960" y="4912512"/>
-            <a:ext cx="5760720" cy="1249324"/>
+        </p:nvPicPr>
+        <p:blipFill>
+          <a:blip r:embed="rId3"/>
+          <a:stretch>
+            <a:fillRect/>
+          </a:stretch>
+        </p:blipFill>
+        <p:spPr>
+          <a:xfrm>
+            <a:off x="822960" y="4892773"/>
+            <a:ext cx="5760720" cy="1436462"/>
           </a:xfrm>
           <a:prstGeom prst="rect">
             <a:avLst/>
           </a:prstGeom>
-          <a:noFill/>
-        </p:spPr>
-        <p:txBody>
-          <a:bodyPr wrap="square">
-            <a:spAutoFit/>
-          </a:bodyPr>
-          <a:lstStyle/>
-          <a:p>
-            <a:pPr algn="l">
-              <a:lnSpc>
-                <a:spcPct val="130000"/>
-              </a:lnSpc>
-              <a:spcAft>
-                <a:spcPts val="0"/>
-              </a:spcAft>
-            </a:pPr>
-            <a:r>
-              <a:rPr sz="1400" b="0">
-                <a:solidFill>
-                  <a:srgbClr val="1A1A19"/>
-                </a:solidFill>
-                <a:latin typeface="Consolas"/>
-              </a:rPr>
-              <a:t>A.  t* = max t  s.t.  r_i ≥ t·Ĝ_i  ∀ GBR</a:t>
-            </a:r>
-          </a:p>
-          <a:p>
-            <a:pPr algn="l">
-              <a:lnSpc>
-                <a:spcPct val="110000"/>
-              </a:lnSpc>
-              <a:spcAft>
-                <a:spcPts val="700"/>
-              </a:spcAft>
-            </a:pPr>
-            <a:r>
-              <a:rPr sz="1100" b="0">
-                <a:solidFill>
-                  <a:srgbClr val="8A8980"/>
-                </a:solidFill>
-                <a:latin typeface="Calibri"/>
-              </a:rPr>
-              <a:t>then  floor_i = α·t*·Ĝ_i</a:t>
-            </a:r>
-          </a:p>
-          <a:p>
-            <a:pPr algn="l">
-              <a:lnSpc>
-                <a:spcPct val="130000"/>
-              </a:lnSpc>
-              <a:spcAft>
-                <a:spcPts val="700"/>
-              </a:spcAft>
-            </a:pPr>
-            <a:r>
-              <a:rPr sz="1400" b="0">
-                <a:solidFill>
-                  <a:srgbClr val="1A1A19"/>
-                </a:solidFill>
-                <a:latin typeface="Consolas"/>
-              </a:rPr>
-              <a:t>B1. S* = min Σ p_i·s_i + p_σ Σ SE_σ·s_σ</a:t>
-            </a:r>
-          </a:p>
-          <a:p>
-            <a:pPr algn="l">
-              <a:lnSpc>
-                <a:spcPct val="130000"/>
-              </a:lnSpc>
-              <a:spcAft>
-                <a:spcPts val="700"/>
-              </a:spcAft>
-            </a:pPr>
-            <a:r>
-              <a:rPr sz="1400" b="0">
-                <a:solidFill>
-                  <a:srgbClr val="1A1A19"/>
-                </a:solidFill>
-                <a:latin typeface="Consolas"/>
-              </a:rPr>
-              <a:t>B2.      max Σ w_c·log(r_i+ε)  s.t. Σ p_i·s_i ≤ S*</a:t>
-            </a:r>
-          </a:p>
-        </p:txBody>
-      </p:sp>
+        </p:spPr>
+      </p:pic>
       <p:sp>
         <p:nvSpPr>
           <p:cNvPr id="9" name="Rectangle 8"/>
@@ -7022,124 +6796,30 @@
           </a:p>
         </p:txBody>
       </p:sp>
-      <p:sp>
-        <p:nvSpPr>
-          <p:cNvPr id="6" name="TextBox 5"/>
-          <p:cNvSpPr txBox="1"/>
+      <p:pic>
+        <p:nvPicPr>
+          <p:cNvPr id="6" name="Picture 5" descr="eq-0fd006bf10302264.png"/>
+          <p:cNvPicPr>
+            <a:picLocks noChangeAspect="1"/>
+          </p:cNvPicPr>
           <p:nvPr/>
-        </p:nvSpPr>
+        </p:nvPicPr>
+        <p:blipFill>
+          <a:blip r:embed="rId2"/>
+          <a:stretch>
+            <a:fillRect/>
+          </a:stretch>
+        </p:blipFill>
         <p:spPr>
           <a:xfrm>
             <a:off x="822960" y="2420874"/>
-            <a:ext cx="5760720" cy="1427581"/>
+            <a:ext cx="5760720" cy="1119470"/>
           </a:xfrm>
           <a:prstGeom prst="rect">
             <a:avLst/>
           </a:prstGeom>
-          <a:noFill/>
-        </p:spPr>
-        <p:txBody>
-          <a:bodyPr wrap="square">
-            <a:spAutoFit/>
-          </a:bodyPr>
-          <a:lstStyle/>
-          <a:p>
-            <a:pPr algn="l">
-              <a:lnSpc>
-                <a:spcPct val="130000"/>
-              </a:lnSpc>
-              <a:spcAft>
-                <a:spcPts val="0"/>
-              </a:spcAft>
-            </a:pPr>
-            <a:r>
-              <a:rPr sz="1400" b="0">
-                <a:solidFill>
-                  <a:srgbClr val="1A1A19"/>
-                </a:solidFill>
-                <a:latin typeface="Consolas"/>
-              </a:rPr>
-              <a:t>Q_i += r_i·Δ ;  Q_i ← min(Q_i, ceil_i)</a:t>
-            </a:r>
-          </a:p>
-          <a:p>
-            <a:pPr algn="l">
-              <a:lnSpc>
-                <a:spcPct val="110000"/>
-              </a:lnSpc>
-              <a:spcAft>
-                <a:spcPts val="700"/>
-              </a:spcAft>
-            </a:pPr>
-            <a:r>
-              <a:rPr sz="1100" b="0">
-                <a:solidFill>
-                  <a:srgbClr val="8A8980"/>
-                </a:solidFill>
-                <a:latin typeface="Calibri"/>
-              </a:rPr>
-              <a:t>grow by the Tier-1 target, then clamp</a:t>
-            </a:r>
-          </a:p>
-          <a:p>
-            <a:pPr algn="l">
-              <a:lnSpc>
-                <a:spcPct val="130000"/>
-              </a:lnSpc>
-              <a:spcAft>
-                <a:spcPts val="700"/>
-              </a:spcAft>
-            </a:pPr>
-            <a:r>
-              <a:rPr sz="1400" b="0">
-                <a:solidFill>
-                  <a:srgbClr val="1A1A19"/>
-                </a:solidFill>
-                <a:latin typeface="Consolas"/>
-              </a:rPr>
-              <a:t>serve ;  Q_i ← max(0, Q_i − delivered_i)</a:t>
-            </a:r>
-          </a:p>
-          <a:p>
-            <a:pPr algn="l">
-              <a:lnSpc>
-                <a:spcPct val="130000"/>
-              </a:lnSpc>
-              <a:spcAft>
-                <a:spcPts val="0"/>
-              </a:spcAft>
-            </a:pPr>
-            <a:r>
-              <a:rPr sz="1400" b="0">
-                <a:solidFill>
-                  <a:srgbClr val="1A1A19"/>
-                </a:solidFill>
-                <a:latin typeface="Consolas"/>
-              </a:rPr>
-              <a:t>ceil_i = max(0, min(r_i·W, A_i^W) − D_i^W)</a:t>
-            </a:r>
-          </a:p>
-          <a:p>
-            <a:pPr algn="l">
-              <a:lnSpc>
-                <a:spcPct val="110000"/>
-              </a:lnSpc>
-              <a:spcAft>
-                <a:spcPts val="700"/>
-              </a:spcAft>
-            </a:pPr>
-            <a:r>
-              <a:rPr sz="1100" b="0">
-                <a:solidFill>
-                  <a:srgbClr val="8A8980"/>
-                </a:solidFill>
-                <a:latin typeface="Calibri"/>
-              </a:rPr>
-              <a:t>the debt the flow legitimately accrued over the window W</a:t>
-            </a:r>
-          </a:p>
-        </p:txBody>
-      </p:sp>
+        </p:spPr>
+      </p:pic>
       <p:sp>
         <p:nvSpPr>
           <p:cNvPr id="7" name="TextBox 6"/>
@@ -7148,7 +6828,7 @@
         </p:nvSpPr>
         <p:spPr>
           <a:xfrm>
-            <a:off x="822960" y="3994759"/>
+            <a:off x="822960" y="3686648"/>
             <a:ext cx="5760720" cy="352424"/>
           </a:xfrm>
           <a:prstGeom prst="rect">
@@ -7182,16 +6862,40 @@
           </a:p>
         </p:txBody>
       </p:sp>
-      <p:sp>
-        <p:nvSpPr>
-          <p:cNvPr id="8" name="TextBox 7"/>
+      <p:pic>
+        <p:nvPicPr>
+          <p:cNvPr id="8" name="Picture 7" descr="eq-bcb1b5e8bb20f488.png"/>
+          <p:cNvPicPr>
+            <a:picLocks noChangeAspect="1"/>
+          </p:cNvPicPr>
+          <p:nvPr/>
+        </p:nvPicPr>
+        <p:blipFill>
+          <a:blip r:embed="rId3"/>
+          <a:stretch>
+            <a:fillRect/>
+          </a:stretch>
+        </p:blipFill>
+        <p:spPr>
+          <a:xfrm>
+            <a:off x="822960" y="4167089"/>
+            <a:ext cx="5760720" cy="994141"/>
+          </a:xfrm>
+          <a:prstGeom prst="rect">
+            <a:avLst/>
+          </a:prstGeom>
+        </p:spPr>
+      </p:pic>
+      <p:sp>
+        <p:nvSpPr>
+          <p:cNvPr id="9" name="TextBox 8"/>
           <p:cNvSpPr txBox="1"/>
           <p:nvPr/>
         </p:nvSpPr>
         <p:spPr>
           <a:xfrm>
-            <a:off x="822960" y="4475200"/>
-            <a:ext cx="5760720" cy="1427581"/>
+            <a:off x="822960" y="5289246"/>
+            <a:ext cx="5760720" cy="904875"/>
           </a:xfrm>
           <a:prstGeom prst="rect">
             <a:avLst/>
@@ -7206,110 +6910,34 @@
           <a:p>
             <a:pPr algn="l">
               <a:lnSpc>
-                <a:spcPct val="130000"/>
+                <a:spcPct val="125000"/>
               </a:lnSpc>
               <a:spcAft>
-                <a:spcPts val="0"/>
+                <a:spcPts val="600"/>
               </a:spcAft>
             </a:pPr>
             <a:r>
-              <a:rPr sz="1400" b="0">
-                <a:solidFill>
-                  <a:srgbClr val="1A1A19"/>
-                </a:solidFill>
-                <a:latin typeface="Consolas"/>
-              </a:rPr>
-              <a:t>Q̃_i = Q_i + w_d·(HoL_i/PDB_i)^κ · max_j Q_j</a:t>
-            </a:r>
-          </a:p>
-          <a:p>
-            <a:pPr algn="l">
-              <a:lnSpc>
-                <a:spcPct val="110000"/>
-              </a:lnSpc>
-              <a:spcAft>
-                <a:spcPts val="700"/>
-              </a:spcAft>
-            </a:pPr>
-            <a:r>
-              <a:rPr sz="1100" b="0">
-                <a:solidFill>
-                  <a:srgbClr val="8A8980"/>
-                </a:solidFill>
-                <a:latin typeface="Calibri"/>
-              </a:rPr>
-              <a:t>deadline urgency, scaled by the system-wide max queue</a:t>
-            </a:r>
-          </a:p>
-          <a:p>
-            <a:pPr algn="l">
-              <a:lnSpc>
-                <a:spcPct val="130000"/>
-              </a:lnSpc>
-              <a:spcAft>
-                <a:spcPts val="0"/>
-              </a:spcAft>
-            </a:pPr>
-            <a:r>
-              <a:rPr sz="1400" b="0">
-                <a:solidFill>
-                  <a:srgbClr val="1A1A19"/>
-                </a:solidFill>
-                <a:latin typeface="Consolas"/>
-              </a:rPr>
-              <a:t>M_u = ( Σ_{i∈u} Q̃_i ) · SE_u</a:t>
-            </a:r>
-          </a:p>
-          <a:p>
-            <a:pPr algn="l">
-              <a:lnSpc>
-                <a:spcPct val="110000"/>
-              </a:lnSpc>
-              <a:spcAft>
-                <a:spcPts val="700"/>
-              </a:spcAft>
-            </a:pPr>
-            <a:r>
-              <a:rPr sz="1100" b="0">
-                <a:solidFill>
-                  <a:srgbClr val="8A8980"/>
-                </a:solidFill>
-                <a:latin typeface="Calibri"/>
-              </a:rPr>
-              <a:t>rank UEs — opportunistic and rate-tracking at once</a:t>
-            </a:r>
-          </a:p>
-          <a:p>
-            <a:pPr algn="l">
-              <a:lnSpc>
-                <a:spcPct val="130000"/>
-              </a:lnSpc>
-              <a:spcAft>
-                <a:spcPts val="700"/>
-              </a:spcAft>
-            </a:pPr>
-            <a:r>
-              <a:rPr sz="1400" b="0">
-                <a:solidFill>
-                  <a:srgbClr val="1A1A19"/>
-                </a:solidFill>
-                <a:latin typeface="Consolas"/>
-              </a:rPr>
-              <a:t>fill the TB by TS 38.321 LCP: priority, then Q̃_i</a:t>
-            </a:r>
-          </a:p>
-        </p:txBody>
-      </p:sp>
-      <p:sp>
-        <p:nvSpPr>
-          <p:cNvPr id="9" name="Rectangle 8"/>
+              <a:rPr sz="1500" b="0">
+                <a:solidFill>
+                  <a:srgbClr val="5C5B54"/>
+                </a:solidFill>
+                <a:latin typeface="Calibri"/>
+              </a:rPr>
+              <a:t>The granted transport block is then filled by TS 38.321 logical-channel prioritisation: by priority level, then by adjusted queue.</a:t>
+            </a:r>
+          </a:p>
+        </p:txBody>
+      </p:sp>
+      <p:sp>
+        <p:nvSpPr>
+          <p:cNvPr id="10" name="Rectangle 9"/>
           <p:cNvSpPr/>
           <p:nvPr/>
         </p:nvSpPr>
         <p:spPr>
           <a:xfrm>
             <a:off x="6949440" y="1691640"/>
-            <a:ext cx="4434840" cy="1546859"/>
+            <a:ext cx="4434840" cy="1823085"/>
           </a:xfrm>
           <a:prstGeom prst="rect">
             <a:avLst/>
@@ -7346,14 +6974,14 @@
       </p:sp>
       <p:sp>
         <p:nvSpPr>
-          <p:cNvPr id="10" name="Rectangle 9"/>
+          <p:cNvPr id="11" name="Rectangle 10"/>
           <p:cNvSpPr/>
           <p:nvPr/>
         </p:nvSpPr>
         <p:spPr>
           <a:xfrm>
             <a:off x="6949440" y="1691640"/>
-            <a:ext cx="50800" cy="1546859"/>
+            <a:ext cx="50800" cy="1823085"/>
           </a:xfrm>
           <a:prstGeom prst="rect">
             <a:avLst/>
@@ -7390,14 +7018,14 @@
       </p:sp>
       <p:sp>
         <p:nvSpPr>
-          <p:cNvPr id="11" name="TextBox 10"/>
+          <p:cNvPr id="12" name="TextBox 11"/>
           <p:cNvSpPr txBox="1"/>
           <p:nvPr/>
         </p:nvSpPr>
         <p:spPr>
           <a:xfrm>
             <a:off x="7178040" y="1828800"/>
-            <a:ext cx="3977640" cy="1272539"/>
+            <a:ext cx="3977640" cy="1548765"/>
           </a:xfrm>
           <a:prstGeom prst="rect">
             <a:avLst/>
@@ -7425,7 +7053,7 @@
                 </a:solidFill>
                 <a:latin typeface="Calibri"/>
               </a:rPr>
-              <a:t>Q_i is a </a:t>
+              <a:t>The virtual queue is a </a:t>
             </a:r>
             <a:r>
               <a:rPr sz="1500" b="1">
@@ -7450,13 +7078,13 @@
       </p:sp>
       <p:sp>
         <p:nvSpPr>
-          <p:cNvPr id="12" name="Rectangle 11"/>
+          <p:cNvPr id="13" name="Rectangle 12"/>
           <p:cNvSpPr/>
           <p:nvPr/>
         </p:nvSpPr>
         <p:spPr>
           <a:xfrm>
-            <a:off x="6949440" y="3421379"/>
+            <a:off x="6949440" y="3697605"/>
             <a:ext cx="4434840" cy="1546859"/>
           </a:xfrm>
           <a:prstGeom prst="rect">
@@ -7494,13 +7122,13 @@
       </p:sp>
       <p:sp>
         <p:nvSpPr>
-          <p:cNvPr id="13" name="Rectangle 12"/>
+          <p:cNvPr id="14" name="Rectangle 13"/>
           <p:cNvSpPr/>
           <p:nvPr/>
         </p:nvSpPr>
         <p:spPr>
           <a:xfrm>
-            <a:off x="6949440" y="3421379"/>
+            <a:off x="6949440" y="3697605"/>
             <a:ext cx="50800" cy="1546859"/>
           </a:xfrm>
           <a:prstGeom prst="rect">
@@ -7538,13 +7166,13 @@
       </p:sp>
       <p:sp>
         <p:nvSpPr>
-          <p:cNvPr id="14" name="TextBox 13"/>
+          <p:cNvPr id="15" name="TextBox 14"/>
           <p:cNvSpPr txBox="1"/>
           <p:nvPr/>
         </p:nvSpPr>
         <p:spPr>
           <a:xfrm>
-            <a:off x="7178040" y="3558539"/>
+            <a:off x="7178040" y="3834765"/>
             <a:ext cx="3977640" cy="1272539"/>
           </a:xfrm>
           <a:prstGeom prst="rect">
@@ -7598,13 +7226,13 @@
       </p:sp>
       <p:sp>
         <p:nvSpPr>
-          <p:cNvPr id="15" name="Rectangle 14"/>
+          <p:cNvPr id="16" name="Rectangle 15"/>
           <p:cNvSpPr/>
           <p:nvPr/>
         </p:nvSpPr>
         <p:spPr>
           <a:xfrm>
-            <a:off x="6949440" y="5151118"/>
+            <a:off x="6949440" y="5427344"/>
             <a:ext cx="4434840" cy="1546859"/>
           </a:xfrm>
           <a:prstGeom prst="rect">
@@ -7642,13 +7270,13 @@
       </p:sp>
       <p:sp>
         <p:nvSpPr>
-          <p:cNvPr id="16" name="Rectangle 15"/>
+          <p:cNvPr id="17" name="Rectangle 16"/>
           <p:cNvSpPr/>
           <p:nvPr/>
         </p:nvSpPr>
         <p:spPr>
           <a:xfrm>
-            <a:off x="6949440" y="5151118"/>
+            <a:off x="6949440" y="5427344"/>
             <a:ext cx="50800" cy="1546859"/>
           </a:xfrm>
           <a:prstGeom prst="rect">
@@ -7686,13 +7314,13 @@
       </p:sp>
       <p:sp>
         <p:nvSpPr>
-          <p:cNvPr id="17" name="TextBox 16"/>
+          <p:cNvPr id="18" name="TextBox 17"/>
           <p:cNvSpPr txBox="1"/>
           <p:nvPr/>
         </p:nvSpPr>
         <p:spPr>
           <a:xfrm>
-            <a:off x="7178040" y="5288278"/>
+            <a:off x="7178040" y="5564504"/>
             <a:ext cx="3977640" cy="1272539"/>
           </a:xfrm>
           <a:prstGeom prst="rect">

</xml_diff>